<commit_message>
Refine messaging: tone down claims, use AWS Student Builder Campus Leader, and remove 'official' throughout
</commit_message>
<xml_diff>
--- a/AWS_Builder_Center_Class_Announcement.pptx
+++ b/AWS_Builder_Center_Class_Announcement.pptx
@@ -3383,7 +3383,7 @@
               </a:defRPr>
             </a:pPr>
             <a:r>
-              <a:t>AWS Student Builder Campus Leader (SBCL)  •  builder.aws.com  •  #awssbcl</a:t>
+              <a:t>AWS Student Builder Campus Leader (SBCL)  •  @bhatsathwik  •  builder.aws.com</a:t>
             </a:r>
           </a:p>
         </p:txBody>
@@ -3653,7 +3653,7 @@
               </a:defRPr>
             </a:pPr>
             <a:r>
-              <a:t>Officially selected by Amazon Web Services to represent AWS on our campus, bridging the gap between classroom academics and real-world cloud &amp; AI technology.</a:t>
+              <a:t>AWS Student Builder Campus Leader (SBCL) on our campus, helping students explore real-world cloud computing, GenAI tools, and certification guidance.</a:t>
             </a:r>
           </a:p>
           <a:p>
@@ -3768,7 +3768,7 @@
               </a:defRPr>
             </a:pPr>
             <a:r>
-              <a:t>Direct bridge to official AWS resources, developer community programs, hackathons, and global technical challenges.</a:t>
+              <a:t>Direct bridge to AWS learning resources, developer community programs, hackathons, and technical challenges.</a:t>
             </a:r>
           </a:p>
         </p:txBody>
@@ -4033,7 +4033,7 @@
               </a:defRPr>
             </a:pPr>
             <a:r>
-              <a:t>THE OFFICIAL COMMUNITY PLATFORM</a:t>
+              <a:t>THE BUILDER COMMUNITY PLATFORM</a:t>
             </a:r>
           </a:p>
         </p:txBody>
@@ -4592,7 +4592,7 @@
               </a:defRPr>
             </a:pPr>
             <a:r>
-              <a:t>Full access to official AWS Skill Builder courses, curated learning paths for Cloud Practitioner, AI &amp; Solutions Architecture.</a:t>
+              <a:t>Full access to AWS Skill Builder courses, curated learning paths for Cloud Practitioner, AI &amp; Solutions Architecture.</a:t>
             </a:r>
           </a:p>
         </p:txBody>

</xml_diff>

<commit_message>
Update deck and web presentation: replace prohibited marketing claims with brand-compliant hooks and student rewards
</commit_message>
<xml_diff>
--- a/AWS_Builder_Center_Class_Announcement.pptx
+++ b/AWS_Builder_Center_Class_Announcement.pptx
@@ -3823,7 +3823,7 @@
               </a:defRPr>
             </a:pPr>
             <a:r>
-              <a:t>02.  Free Cloud &amp; AI Learning for Everyone</a:t>
+              <a:t>02.  Hands-On Cloud &amp; GenAI Skill Pathways</a:t>
             </a:r>
           </a:p>
           <a:p>
@@ -3839,7 +3839,7 @@
               </a:defRPr>
             </a:pPr>
             <a:r>
-              <a:t>Enabling peers across all branches and years to master high-demand cloud and GenAI tools at zero cost.</a:t>
+              <a:t>Empowering peers across all branches and years with guided learning, next-gen AI tools, and hands-on workshops.</a:t>
             </a:r>
           </a:p>
         </p:txBody>
@@ -4225,7 +4225,7 @@
               </a:defRPr>
             </a:pPr>
             <a:r>
-              <a:t>•  Hands-On Labs &amp; Toolboxes: </a:t>
+              <a:t>•  Hands-On Sandboxes &amp; GenAI Tools: </a:t>
             </a:r>
             <a:r>
               <a:rPr b="0">
@@ -4233,7 +4233,7 @@
                   <a:srgbClr val="94A3B8"/>
                 </a:solidFill>
               </a:rPr>
-              <a:t>Explore AWS Free Tier, Serverless tools, and guided workshops without complex billing risk.</a:t>
+              <a:t>Build live cloud projects, experiment with PartyRock &amp; Amazon Bedrock, and explore serverless architectures with guided sandboxes.</a:t>
             </a:r>
           </a:p>
         </p:txBody>
@@ -4576,7 +4576,7 @@
               </a:defRPr>
             </a:pPr>
             <a:r>
-              <a:t>600+ Free Courses</a:t>
+              <a:t>Curated Skill Builder Tracks</a:t>
             </a:r>
           </a:p>
           <a:p>
@@ -4592,7 +4592,7 @@
               </a:defRPr>
             </a:pPr>
             <a:r>
-              <a:t>Full access to AWS Skill Builder courses, curated learning paths for Cloud Practitioner, AI &amp; Solutions Architecture.</a:t>
+              <a:t>Comprehensive on-demand curriculum and guided paths for Cloud Practitioner, Solutions Architect, and Generative AI.</a:t>
             </a:r>
           </a:p>
         </p:txBody>
@@ -4647,7 +4647,7 @@
               </a:defRPr>
             </a:pPr>
             <a:r>
-              <a:t>Hands-On Tutorials &amp; Labs</a:t>
+              <a:t>Student Rewards &amp; Exam Vouchers</a:t>
             </a:r>
           </a:p>
           <a:p>
@@ -4663,7 +4663,7 @@
               </a:defRPr>
             </a:pPr>
             <a:r>
-              <a:t>Step-by-step interactive workshops, serverless labs, and real cloud building experiences right from your browser.</a:t>
+              <a:t>Verify your student status with SheerID to earn milestone badges, AWS cloud credits, and foundational certification exam vouchers.</a:t>
             </a:r>
           </a:p>
         </p:txBody>
@@ -4718,7 +4718,7 @@
               </a:defRPr>
             </a:pPr>
             <a:r>
-              <a:t>Weekly Challenges</a:t>
+              <a:t>Generative AI Innovation Playground</a:t>
             </a:r>
           </a:p>
           <a:p>
@@ -4734,7 +4734,7 @@
               </a:defRPr>
             </a:pPr>
             <a:r>
-              <a:t>Structured problem-solving challenges to test your skills, earn digital credentials, and showcase verified builds on LinkedIn.</a:t>
+              <a:t>Build working AI apps in minutes using PartyRock (Amazon Bedrock) and accelerate coding with Amazon Q Developer.</a:t>
             </a:r>
           </a:p>
         </p:txBody>
@@ -4789,7 +4789,7 @@
               </a:defRPr>
             </a:pPr>
             <a:r>
-              <a:t>Global Tech Network</a:t>
+              <a:t>Verified Builder Profile &amp; Network</a:t>
             </a:r>
           </a:p>
           <a:p>
@@ -4805,7 +4805,7 @@
               </a:defRPr>
             </a:pPr>
             <a:r>
-              <a:t>Direct connection to AWS engineers, student leaders across universities, and unlock mentorship &amp; campus leadership opportunities.</a:t>
+              <a:t>Showcase your real builds on a permanent builder profile (builder.aws.com/@alias) and connect with peers &amp; mentors.</a:t>
             </a:r>
           </a:p>
         </p:txBody>
@@ -4860,7 +4860,7 @@
               </a:defRPr>
             </a:pPr>
             <a:r>
-              <a:t>100% FREE FOR STUDENTS  —  NO CREDIT CARD OR BILLING SETUP REQUIRED</a:t>
+              <a:t>FRICTIONLESS STUDENT ONBOARDING  —  SIGN UP IN 60 SECONDS WITH YOUR AWS BUILDER ID</a:t>
             </a:r>
           </a:p>
         </p:txBody>
@@ -5942,7 +5942,7 @@
               </a:defRPr>
             </a:pPr>
             <a:r>
-              <a:t>•  Instant access to free perks: </a:t>
+              <a:t>•  Instant access to student perks: </a:t>
             </a:r>
             <a:r>
               <a:rPr b="0">
@@ -5950,7 +5950,7 @@
                   <a:srgbClr val="94A3B8"/>
                 </a:solidFill>
               </a:rPr>
-              <a:t>Unlock 600+ Skill Builder courses &amp; hands-on workshops right away.</a:t>
+              <a:t>Unlock comprehensive Skill Builder curriculum, GenAI tools &amp; milestone badges right away.</a:t>
             </a:r>
           </a:p>
           <a:p>

</xml_diff>